<commit_message>
Polish README, presentation, and docs
- Fix spelling and grammar throughout README
- Add missing DELETE /api/products/all endpoint to API table
- Remove Cognito references from presentation (replaced with JWT demo accounts)
- Add CRUD threat reporting mention to security slide
- Expand auth section with Cognito removal rationale
- Rename Code Challenge PDF (remove extra dot)
- Update PowerPoint to match current architecture

Co-Authored-By: Claude Opus 4.6 <noreply@anthropic.com>
</commit_message>
<xml_diff>
--- a/docs/E-Commerce Code Challenge.pptx
+++ b/docs/E-Commerce Code Challenge.pptx
@@ -107,6 +107,11 @@
       </a:defRPr>
     </a:lvl9pPr>
   </p:defaultTextStyle>
+  <p:extLst>
+    <p:ext uri="{EFAFB233-063F-42B5-8137-9DF3F51BA10A}">
+      <p15:sldGuideLst xmlns:p15="http://schemas.microsoft.com/office/powerpoint/2012/main"/>
+    </p:ext>
+  </p:extLst>
 </p:presentation>
 </file>
 
@@ -257,7 +262,7 @@
           <a:p>
             <a:fld id="{D9DE9994-83D4-413F-8D7A-C117FED25A91}" type="datetimeFigureOut">
               <a:rPr lang="en-US" smtClean="0"/>
-              <a:t>8/24/2026</a:t>
+              <a:t>8/25/2026</a:t>
             </a:fld>
             <a:endParaRPr lang="en-US"/>
           </a:p>
@@ -455,7 +460,7 @@
           <a:p>
             <a:fld id="{D9DE9994-83D4-413F-8D7A-C117FED25A91}" type="datetimeFigureOut">
               <a:rPr lang="en-US" smtClean="0"/>
-              <a:t>8/24/2026</a:t>
+              <a:t>8/25/2026</a:t>
             </a:fld>
             <a:endParaRPr lang="en-US"/>
           </a:p>
@@ -663,7 +668,7 @@
           <a:p>
             <a:fld id="{D9DE9994-83D4-413F-8D7A-C117FED25A91}" type="datetimeFigureOut">
               <a:rPr lang="en-US" smtClean="0"/>
-              <a:t>8/24/2026</a:t>
+              <a:t>8/25/2026</a:t>
             </a:fld>
             <a:endParaRPr lang="en-US"/>
           </a:p>
@@ -861,7 +866,7 @@
           <a:p>
             <a:fld id="{D9DE9994-83D4-413F-8D7A-C117FED25A91}" type="datetimeFigureOut">
               <a:rPr lang="en-US" smtClean="0"/>
-              <a:t>8/24/2026</a:t>
+              <a:t>8/25/2026</a:t>
             </a:fld>
             <a:endParaRPr lang="en-US"/>
           </a:p>
@@ -1136,7 +1141,7 @@
           <a:p>
             <a:fld id="{D9DE9994-83D4-413F-8D7A-C117FED25A91}" type="datetimeFigureOut">
               <a:rPr lang="en-US" smtClean="0"/>
-              <a:t>8/24/2026</a:t>
+              <a:t>8/25/2026</a:t>
             </a:fld>
             <a:endParaRPr lang="en-US"/>
           </a:p>
@@ -1401,7 +1406,7 @@
           <a:p>
             <a:fld id="{D9DE9994-83D4-413F-8D7A-C117FED25A91}" type="datetimeFigureOut">
               <a:rPr lang="en-US" smtClean="0"/>
-              <a:t>8/24/2026</a:t>
+              <a:t>8/25/2026</a:t>
             </a:fld>
             <a:endParaRPr lang="en-US"/>
           </a:p>
@@ -1813,7 +1818,7 @@
           <a:p>
             <a:fld id="{D9DE9994-83D4-413F-8D7A-C117FED25A91}" type="datetimeFigureOut">
               <a:rPr lang="en-US" smtClean="0"/>
-              <a:t>8/24/2026</a:t>
+              <a:t>8/25/2026</a:t>
             </a:fld>
             <a:endParaRPr lang="en-US"/>
           </a:p>
@@ -1954,7 +1959,7 @@
           <a:p>
             <a:fld id="{D9DE9994-83D4-413F-8D7A-C117FED25A91}" type="datetimeFigureOut">
               <a:rPr lang="en-US" smtClean="0"/>
-              <a:t>8/24/2026</a:t>
+              <a:t>8/25/2026</a:t>
             </a:fld>
             <a:endParaRPr lang="en-US"/>
           </a:p>
@@ -2067,7 +2072,7 @@
           <a:p>
             <a:fld id="{D9DE9994-83D4-413F-8D7A-C117FED25A91}" type="datetimeFigureOut">
               <a:rPr lang="en-US" smtClean="0"/>
-              <a:t>8/24/2026</a:t>
+              <a:t>8/25/2026</a:t>
             </a:fld>
             <a:endParaRPr lang="en-US"/>
           </a:p>
@@ -2378,7 +2383,7 @@
           <a:p>
             <a:fld id="{D9DE9994-83D4-413F-8D7A-C117FED25A91}" type="datetimeFigureOut">
               <a:rPr lang="en-US" smtClean="0"/>
-              <a:t>8/24/2026</a:t>
+              <a:t>8/25/2026</a:t>
             </a:fld>
             <a:endParaRPr lang="en-US"/>
           </a:p>
@@ -2666,7 +2671,7 @@
           <a:p>
             <a:fld id="{D9DE9994-83D4-413F-8D7A-C117FED25A91}" type="datetimeFigureOut">
               <a:rPr lang="en-US" smtClean="0"/>
-              <a:t>8/24/2026</a:t>
+              <a:t>8/25/2026</a:t>
             </a:fld>
             <a:endParaRPr lang="en-US"/>
           </a:p>
@@ -2910,7 +2915,7 @@
           <a:p>
             <a:fld id="{D9DE9994-83D4-413F-8D7A-C117FED25A91}" type="datetimeFigureOut">
               <a:rPr lang="en-US" smtClean="0"/>
-              <a:t>8/24/2026</a:t>
+              <a:t>8/25/2026</a:t>
             </a:fld>
             <a:endParaRPr lang="en-US"/>
           </a:p>
@@ -4393,7 +4398,7 @@
                   <a:srgbClr val="3E4C5A"/>
                 </a:solidFill>
               </a:rPr>
-              <a:t>The core functionality is also the most vulnerable entry point. I identified and neutralized two attack types embedded in the provided CSV:</a:t>
+              <a:t>The core functionality is also the most vulnerable entry point. I identified and handled two attack types embedded in the provided CSV:</a:t>
             </a:r>
           </a:p>
           <a:p>
@@ -4679,7 +4684,7 @@
                   <a:srgbClr val="3E4C5A"/>
                 </a:solidFill>
               </a:rPr>
-              <a:t>A detection layer scans raw CSV values before sanitization and logs every attack. The import UI shows a “Threats Blocked” panel with type, line number, and action taken.</a:t>
+              <a:t>A detection layer scans raw CSV values before sanitization and logs every attack. The import UI shows the thread and action taken.</a:t>
             </a:r>
           </a:p>
         </p:txBody>
@@ -4794,7 +4799,7 @@
                   <a:srgbClr val="3E4C5A"/>
                 </a:solidFill>
               </a:rPr>
-              <a:t>Deployed to the web to test scenarios that only surface in production: larger files, concurrent requests, and more robust attack patterns.</a:t>
+              <a:t>Deployed to the web to test different scenarios against deployed resources limitations.</a:t>
             </a:r>
           </a:p>
         </p:txBody>
@@ -4936,7 +4941,7 @@
                   <a:srgbClr val="2C3E50"/>
                 </a:solidFill>
               </a:rPr>
-              <a:t>Strip script tags via regex before storage</a:t>
+              <a:t>Skip insertion of records with threads</a:t>
             </a:r>
           </a:p>
         </p:txBody>
@@ -5318,8 +5323,8 @@
         </p:nvSpPr>
         <p:spPr>
           <a:xfrm>
-            <a:off x="1016000" y="2590800"/>
-            <a:ext cx="2057400" cy="2489200"/>
+            <a:off x="864066" y="2590800"/>
+            <a:ext cx="2361734" cy="2489200"/>
           </a:xfrm>
           <a:prstGeom prst="rect">
             <a:avLst/>
@@ -5383,7 +5388,7 @@
                   <a:srgbClr val="33414E"/>
                 </a:solidFill>
               </a:rPr>
-              <a:t>Cognito authentication with JWT tokens (Auth0 pattern)</a:t>
+              <a:t>RABC (partial)</a:t>
             </a:r>
           </a:p>
           <a:p>
@@ -5516,8 +5521,8 @@
         </p:nvSpPr>
         <p:spPr>
           <a:xfrm>
-            <a:off x="3733800" y="2590800"/>
-            <a:ext cx="2057400" cy="2489200"/>
+            <a:off x="3581399" y="2590800"/>
+            <a:ext cx="2332839" cy="2489200"/>
           </a:xfrm>
           <a:prstGeom prst="rect">
             <a:avLst/>
@@ -5714,8 +5719,8 @@
         </p:nvSpPr>
         <p:spPr>
           <a:xfrm>
-            <a:off x="6451600" y="2590800"/>
-            <a:ext cx="2057400" cy="2489200"/>
+            <a:off x="6346272" y="2590800"/>
+            <a:ext cx="2315128" cy="2489200"/>
           </a:xfrm>
           <a:prstGeom prst="rect">
             <a:avLst/>
@@ -5912,8 +5917,8 @@
         </p:nvSpPr>
         <p:spPr>
           <a:xfrm>
-            <a:off x="9169400" y="2590800"/>
-            <a:ext cx="2057400" cy="2489200"/>
+            <a:off x="9060110" y="2590800"/>
+            <a:ext cx="2267824" cy="2489200"/>
           </a:xfrm>
           <a:prstGeom prst="rect">
             <a:avLst/>
@@ -6073,7 +6078,7 @@
                   <a:srgbClr val="46596B"/>
                 </a:solidFill>
               </a:rPr>
-              <a:t>The job description called out AWS, CI/CD, and infrastructure — this demonstrates not just familiarity, but practical experience delivering production-ready solutions across the full stack.</a:t>
+              <a:t>The job post description described out AWS, CI/CD, and infrastructure — this is the reason I added it to demonstrate I have practical experience delivering production-ready solutions across the full stack.</a:t>
             </a:r>
           </a:p>
         </p:txBody>

</xml_diff>